<commit_message>
fix: show scheduled alerts as full-screen broadcast popups and allow opening them from notifications panel directly
</commit_message>
<xml_diff>
--- a/public/assets/CareInn-Welcome-Slideshow-screenshots.pptx
+++ b/public/assets/CareInn-Welcome-Slideshow-screenshots.pptx
@@ -2438,8 +2438,8 @@
 </file>
 
 <file path=customXml/item1.xml><?xml version="1.0" encoding="utf-8"?>
-<ct:contentTypeSchema xmlns:ct="http://schemas.microsoft.com/office/2006/metadata/contentType" xmlns:ma="http://schemas.microsoft.com/office/2006/metadata/properties/metaAttributes" ct:_="" ma:_="" ma:contentTypeName="Document" ma:contentTypeID="0x010100CB20ED7B3ACC9A448772D8ED92073395" ma:contentTypeVersion="14" ma:contentTypeDescription="Create a new document." ma:contentTypeScope="" ma:versionID="93528e17aebef321588520b4a022c871">
-  <xsd:schema xmlns:xsd="http://www.w3.org/2001/XMLSchema" xmlns:xs="http://www.w3.org/2001/XMLSchema" xmlns:p="http://schemas.microsoft.com/office/2006/metadata/properties" xmlns:ns2="ab2d53e4-646a-474d-9207-ecc137f67b40" xmlns:ns3="e6231078-3c2b-4240-add1-999e0de00c0b" targetNamespace="http://schemas.microsoft.com/office/2006/metadata/properties" ma:root="true" ma:fieldsID="dfd9b1f23c064fe24090f1d951628e3c" ns2:_="" ns3:_="">
+<ct:contentTypeSchema xmlns:ct="http://schemas.microsoft.com/office/2006/metadata/contentType" xmlns:ma="http://schemas.microsoft.com/office/2006/metadata/properties/metaAttributes" ct:_="" ma:_="" ma:contentTypeName="Document" ma:contentTypeID="0x010100CB20ED7B3ACC9A448772D8ED92073395" ma:contentTypeVersion="15" ma:contentTypeDescription="Create a new document." ma:contentTypeScope="" ma:versionID="6b2b80be57777251109f6f965d153be6">
+  <xsd:schema xmlns:xsd="http://www.w3.org/2001/XMLSchema" xmlns:xs="http://www.w3.org/2001/XMLSchema" xmlns:p="http://schemas.microsoft.com/office/2006/metadata/properties" xmlns:ns2="ab2d53e4-646a-474d-9207-ecc137f67b40" xmlns:ns3="e6231078-3c2b-4240-add1-999e0de00c0b" targetNamespace="http://schemas.microsoft.com/office/2006/metadata/properties" ma:root="true" ma:fieldsID="c8907888781ff41108735a3432dede9d" ns2:_="" ns3:_="">
     <xsd:import namespace="ab2d53e4-646a-474d-9207-ecc137f67b40"/>
     <xsd:import namespace="e6231078-3c2b-4240-add1-999e0de00c0b"/>
     <xsd:element name="properties">
@@ -2461,6 +2461,7 @@
                 <xsd:element ref="ns2:MediaServiceDateTaken" minOccurs="0"/>
                 <xsd:element ref="ns2:MediaServiceOCR" minOccurs="0"/>
                 <xsd:element ref="ns2:MediaLengthInSeconds" minOccurs="0"/>
+                <xsd:element ref="ns2:MediaServiceBillingMetadata" minOccurs="0"/>
               </xsd:all>
             </xsd:complexType>
           </xsd:element>
@@ -2523,6 +2524,11 @@
     <xsd:element name="MediaLengthInSeconds" ma:index="21" nillable="true" ma:displayName="MediaLengthInSeconds" ma:hidden="true" ma:internalName="MediaLengthInSeconds" ma:readOnly="true">
       <xsd:simpleType>
         <xsd:restriction base="dms:Unknown"/>
+      </xsd:simpleType>
+    </xsd:element>
+    <xsd:element name="MediaServiceBillingMetadata" ma:index="22" nillable="true" ma:displayName="MediaServiceBillingMetadata" ma:hidden="true" ma:internalName="MediaServiceBillingMetadata" ma:readOnly="true">
+      <xsd:simpleType>
+        <xsd:restriction base="dms:Note"/>
       </xsd:simpleType>
     </xsd:element>
   </xsd:schema>
@@ -2687,7 +2693,7 @@
 </file>
 
 <file path=customXml/itemProps1.xml><?xml version="1.0" encoding="utf-8"?>
-<ds:datastoreItem xmlns:ds="http://schemas.openxmlformats.org/officeDocument/2006/customXml" ds:itemID="{0382F1E8-0962-45BC-9DE4-6DF9C86ED27C}"/>
+<ds:datastoreItem xmlns:ds="http://schemas.openxmlformats.org/officeDocument/2006/customXml" ds:itemID="{56E3672C-C60C-4DBE-99B6-0C476D5697C4}"/>
 </file>
 
 <file path=customXml/itemProps2.xml><?xml version="1.0" encoding="utf-8"?>

</xml_diff>